<commit_message>
docs(deck): finalize 6-slide PowerPoint deck with completely filled Our Team roster and submission links
</commit_message>
<xml_diff>
--- a/Atlanta_Heat_Resilience_Deck.pptx
+++ b/Atlanta_Heat_Resilience_Deck.pptx
@@ -647,7 +647,7 @@
           <a:lstStyle/>
           <a:p>
             <a:r>
-              <a:t>"Our four-person team split into parallel engineering lanes—Data &amp; Medallion Architecture, BigQuery ML &amp; Equity Analytics, ADK Agent &amp; Managed MCP Toolbox, and Full-Stack Geospatial UI—governed by a shared contract and decision log (DEC-001 through DEC-011)."</a:t>
+              <a:t>"Our four-person team split into parallel engineering lanes—Data &amp; Medallion Architecture, BigQuery ML &amp; Equity Analytics, ADK Agent &amp; Managed MCP Toolbox, and Full-Stack Geospatial UI—governed by a shared contract and decision log (DEC-001 through DEC-016)."</a:t>
             </a:r>
           </a:p>
         </p:txBody>
@@ -6375,7 +6375,7 @@
                 </a:solidFill>
                 <a:latin typeface="Calibri"/>
               </a:rPr>
-              <a:t>"Our four-person team split into parallel engineering lanes—Data &amp; Medallion Architecture, BigQuery ML &amp; Equity Analytics, ADK Agent &amp; Managed MCP Toolbox, and Full-Stack Geospatial UI—governed by a shared contract and decision log (DEC-001 through DEC-011)."</a:t>
+              <a:t>"Our four-person team split into parallel engineering lanes—Data &amp; Medallion Architecture, BigQuery ML &amp; Equity Analytics, ADK Agent &amp; Managed MCP Toolbox, and Full-Stack Geospatial UI—governed by a shared contract and decision log (DEC-001 through DEC-016)."</a:t>
             </a:r>
           </a:p>
         </p:txBody>
@@ -6813,7 +6813,7 @@
                 </a:solidFill>
                 <a:latin typeface="Calibri"/>
               </a:rPr>
-              <a:t>Google ADK + Gemini 2.5 Flash: </a:t>
+              <a:t>Google ADK + Gemini 3 / 2.5 Flash: </a:t>
             </a:r>
             <a:r>
               <a:rPr b="0" sz="1130">
@@ -6822,7 +6822,7 @@
                 </a:solidFill>
                 <a:latin typeface="Calibri"/>
               </a:rPr>
-              <a:t>Multi-agent orchestrator calling custom Python tools (explain_heat_offset, select_cooling_center_sites, run_equity_audit) + GroundingVerifier.</a:t>
+              <a:t>Two-stage ADK orchestrator (gemini-3-flash-preview ~1.2s routing) calling custom tools (explain_heat_offset, select_cooling_center_sites, run_equity_audit) + GroundingVerifier ([Pn] provenance) &amp; VizSpecBuilder.</a:t>
             </a:r>
           </a:p>
           <a:p>
@@ -6847,7 +6847,7 @@
                 </a:solidFill>
                 <a:latin typeface="Calibri"/>
               </a:rPr>
-              <a:t>Managed MCP Server (heat-toolbox): </a:t>
+              <a:t>3-Service Cloud Run Stack (DEC-012): </a:t>
             </a:r>
             <a:r>
               <a:rPr b="0" sz="1130">
@@ -6856,7 +6856,7 @@
                 </a:solidFill>
                 <a:latin typeface="Calibri"/>
               </a:rPr>
-              <a:t>Cloud Run MCP Toolbox for Databases exposing parameterized SQL tools over a4i_semantic (dim_tract, site_hot_days, vulnerable_population) with least-privilege IAM (toolbox-sa, heat-agent-sa).</a:t>
+              <a:t>Decoupled Cloud Run services: (1) heat-toolbox MCP Server (port 8080, toolbox-sa), (2) heat-planner-api / urban-heat-agent ADK API (port 8000, heat-agent-sa), (3) urban-heat-ui Next.js 16 (port 3000, min-instances=1).</a:t>
             </a:r>
           </a:p>
           <a:p>
@@ -8411,7 +8411,7 @@
                 </a:solidFill>
                 <a:latin typeface="Calibri"/>
               </a:rPr>
-              <a:t>Live Demo &amp; Agent URLs: </a:t>
+              <a:t>Live Demo &amp; Cloud Run URLs: </a:t>
             </a:r>
             <a:r>
               <a:rPr b="0" sz="1100">
@@ -8420,7 +8420,7 @@
                 </a:solidFill>
                 <a:latin typeface="Calibri"/>
               </a:rPr>
-              <a:t>UI: https://urban-heat-ui-1042443035046.us-central1.run.app | Agent: https://urban-heat-agent-1042443035046.us-central1.run.app</a:t>
+              <a:t>UI: https://urban-heat-ui-1042443035046.us-central1.run.app | API: https://heat-planner-api-1042443035046.us-central1.run.app | MCP: https://heat-toolbox-1042443035046.us-central1.run.app</a:t>
             </a:r>
           </a:p>
         </p:txBody>

</xml_diff>